<commit_message>
Final file upload and files' opening system bugs solved.
Correct versioning
</commit_message>
<xml_diff>
--- a/data/memories/memory_01/assets/documents/presentations/Presentation OLD.pptx
+++ b/data/memories/memory_01/assets/documents/presentations/Presentation OLD.pptx
@@ -6,6 +6,11 @@
   </p:sldMasterIdLst>
   <p:sldIdLst>
     <p:sldId id="256" r:id="rId7"/>
+    <p:sldId id="257" r:id="rId8"/>
+    <p:sldId id="258" r:id="rId9"/>
+    <p:sldId id="259" r:id="rId10"/>
+    <p:sldId id="260" r:id="rId11"/>
+    <p:sldId id="261" r:id="rId12"/>
   </p:sldIdLst>
   <p:sldSz cx="9144000" cy="6858000" type="screen4x3"/>
   <p:notesSz cx="6858000" cy="9144000"/>
@@ -3104,193 +3109,474 @@
           <a:lstStyle/>
           <a:p>
             <a:r>
-              <a:t>Quarterly Review Presentation OLD</a:t>
-            </a:r>
-          </a:p>
-        </p:txBody>
-      </p:sp>
-      <p:sp>
-        <p:nvSpPr>
-          <p:cNvPr id="3" name="TextBox 2"/>
-          <p:cNvSpPr txBox="1"/>
-          <p:nvPr/>
-        </p:nvSpPr>
-        <p:spPr>
-          <a:xfrm>
-            <a:off x="640080" y="914400"/>
-            <a:ext cx="7498079" cy="4572000"/>
-          </a:xfrm>
-          <a:prstGeom prst="rect">
-            <a:avLst/>
-          </a:prstGeom>
-          <a:noFill/>
-        </p:spPr>
-        <p:txBody>
-          <a:bodyPr wrap="none">
-            <a:spAutoFit/>
-          </a:bodyPr>
+              <a:t>Quarterly Review</a:t>
+            </a:r>
+          </a:p>
+        </p:txBody>
+      </p:sp>
+      <p:sp>
+        <p:nvSpPr>
+          <p:cNvPr id="3" name="Content Placeholder 2"/>
+          <p:cNvSpPr>
+            <a:spLocks noGrp="1"/>
+          </p:cNvSpPr>
+          <p:nvPr>
+            <p:ph idx="1"/>
+          </p:nvPr>
+        </p:nvSpPr>
+        <p:spPr/>
+        <p:txBody>
+          <a:bodyPr/>
           <a:lstStyle/>
           <a:p>
             <a:pPr>
-              <a:defRPr sz="2000"/>
+              <a:defRPr sz="2200"/>
             </a:pPr>
             <a:r>
-              <a:t>[Unsupported block: slide]</a:t>
-            </a:r>
-          </a:p>
-        </p:txBody>
-      </p:sp>
-      <p:sp>
-        <p:nvSpPr>
-          <p:cNvPr id="4" name="TextBox 3"/>
-          <p:cNvSpPr txBox="1"/>
-          <p:nvPr/>
-        </p:nvSpPr>
-        <p:spPr>
-          <a:xfrm>
-            <a:off x="640080" y="914400"/>
-            <a:ext cx="7498079" cy="4572000"/>
-          </a:xfrm>
-          <a:prstGeom prst="rect">
-            <a:avLst/>
-          </a:prstGeom>
-          <a:noFill/>
-        </p:spPr>
-        <p:txBody>
-          <a:bodyPr wrap="none">
-            <a:spAutoFit/>
-          </a:bodyPr>
-          <a:lstStyle/>
+              <a:t>Internal management presentation.</a:t>
+            </a:r>
+          </a:p>
           <a:p>
             <a:pPr>
-              <a:defRPr sz="2000"/>
+              <a:defRPr sz="2200"/>
             </a:pPr>
             <a:r>
-              <a:t>[Unsupported block: slide]</a:t>
-            </a:r>
-          </a:p>
-        </p:txBody>
-      </p:sp>
-      <p:sp>
-        <p:nvSpPr>
-          <p:cNvPr id="5" name="TextBox 4"/>
-          <p:cNvSpPr txBox="1"/>
-          <p:nvPr/>
-        </p:nvSpPr>
-        <p:spPr>
-          <a:xfrm>
-            <a:off x="640080" y="914400"/>
-            <a:ext cx="7498079" cy="4572000"/>
-          </a:xfrm>
-          <a:prstGeom prst="rect">
-            <a:avLst/>
-          </a:prstGeom>
-          <a:noFill/>
-        </p:spPr>
-        <p:txBody>
-          <a:bodyPr wrap="none">
-            <a:spAutoFit/>
-          </a:bodyPr>
-          <a:lstStyle/>
+              <a:t>Prepared for quarterly operational review.</a:t>
+            </a:r>
+          </a:p>
           <a:p>
             <a:pPr>
-              <a:defRPr sz="2000"/>
+              <a:defRPr sz="2200"/>
             </a:pPr>
             <a:r>
-              <a:t>[Unsupported block: slide]</a:t>
-            </a:r>
-          </a:p>
-        </p:txBody>
-      </p:sp>
-      <p:sp>
-        <p:nvSpPr>
-          <p:cNvPr id="6" name="TextBox 5"/>
-          <p:cNvSpPr txBox="1"/>
-          <p:nvPr/>
-        </p:nvSpPr>
-        <p:spPr>
-          <a:xfrm>
-            <a:off x="640080" y="914400"/>
-            <a:ext cx="7498079" cy="4572000"/>
-          </a:xfrm>
-          <a:prstGeom prst="rect">
-            <a:avLst/>
-          </a:prstGeom>
-          <a:noFill/>
-        </p:spPr>
-        <p:txBody>
-          <a:bodyPr wrap="none">
-            <a:spAutoFit/>
-          </a:bodyPr>
+              <a:t>Draft version - not approved for distribution.</a:t>
+            </a:r>
+          </a:p>
+        </p:txBody>
+      </p:sp>
+    </p:spTree>
+  </p:cSld>
+  <p:clrMapOvr>
+    <a:masterClrMapping/>
+  </p:clrMapOvr>
+</p:sld>
+</file>
+
+<file path=ppt/slides/slide2.xml><?xml version="1.0" encoding="utf-8"?>
+<p:sld xmlns:a="http://schemas.openxmlformats.org/drawingml/2006/main" xmlns:p="http://schemas.openxmlformats.org/presentationml/2006/main" xmlns:r="http://schemas.openxmlformats.org/officeDocument/2006/relationships">
+  <p:cSld>
+    <p:spTree>
+      <p:nvGrpSpPr>
+        <p:cNvPr id="1" name=""/>
+        <p:cNvGrpSpPr/>
+        <p:nvPr/>
+      </p:nvGrpSpPr>
+      <p:grpSpPr/>
+      <p:sp>
+        <p:nvSpPr>
+          <p:cNvPr id="2" name="Title 1"/>
+          <p:cNvSpPr>
+            <a:spLocks noGrp="1"/>
+          </p:cNvSpPr>
+          <p:nvPr>
+            <p:ph type="title"/>
+          </p:nvPr>
+        </p:nvSpPr>
+        <p:spPr/>
+        <p:txBody>
+          <a:bodyPr/>
+          <a:lstStyle/>
+          <a:p>
+            <a:r>
+              <a:t>Agenda</a:t>
+            </a:r>
+          </a:p>
+        </p:txBody>
+      </p:sp>
+      <p:sp>
+        <p:nvSpPr>
+          <p:cNvPr id="3" name="Content Placeholder 2"/>
+          <p:cNvSpPr>
+            <a:spLocks noGrp="1"/>
+          </p:cNvSpPr>
+          <p:nvPr>
+            <p:ph idx="1"/>
+          </p:nvPr>
+        </p:nvSpPr>
+        <p:spPr/>
+        <p:txBody>
+          <a:bodyPr/>
           <a:lstStyle/>
           <a:p>
             <a:pPr>
-              <a:defRPr sz="2000"/>
+              <a:defRPr sz="2200"/>
             </a:pPr>
             <a:r>
-              <a:t>[Unsupported block: slide]</a:t>
-            </a:r>
-          </a:p>
-        </p:txBody>
-      </p:sp>
-      <p:sp>
-        <p:nvSpPr>
-          <p:cNvPr id="7" name="TextBox 6"/>
-          <p:cNvSpPr txBox="1"/>
-          <p:nvPr/>
-        </p:nvSpPr>
-        <p:spPr>
-          <a:xfrm>
-            <a:off x="640080" y="914400"/>
-            <a:ext cx="7498079" cy="4572000"/>
-          </a:xfrm>
-          <a:prstGeom prst="rect">
-            <a:avLst/>
-          </a:prstGeom>
-          <a:noFill/>
-        </p:spPr>
-        <p:txBody>
-          <a:bodyPr wrap="none">
-            <a:spAutoFit/>
-          </a:bodyPr>
-          <a:lstStyle/>
+              <a:t>Financial performance.</a:t>
+            </a:r>
+          </a:p>
           <a:p>
             <a:pPr>
-              <a:defRPr sz="2000"/>
+              <a:defRPr sz="2200"/>
             </a:pPr>
             <a:r>
-              <a:t>[Unsupported block: slide]</a:t>
-            </a:r>
-          </a:p>
-        </p:txBody>
-      </p:sp>
-      <p:sp>
-        <p:nvSpPr>
-          <p:cNvPr id="8" name="TextBox 7"/>
-          <p:cNvSpPr txBox="1"/>
-          <p:nvPr/>
-        </p:nvSpPr>
-        <p:spPr>
-          <a:xfrm>
-            <a:off x="640080" y="914400"/>
-            <a:ext cx="7498079" cy="4572000"/>
-          </a:xfrm>
-          <a:prstGeom prst="rect">
-            <a:avLst/>
-          </a:prstGeom>
-          <a:noFill/>
-        </p:spPr>
-        <p:txBody>
-          <a:bodyPr wrap="none">
-            <a:spAutoFit/>
-          </a:bodyPr>
-          <a:lstStyle/>
+              <a:t>Operational changes.</a:t>
+            </a:r>
+          </a:p>
           <a:p>
             <a:pPr>
-              <a:defRPr sz="2000"/>
+              <a:defRPr sz="2200"/>
             </a:pPr>
             <a:r>
-              <a:t>[Unsupported block: slide]</a:t>
+              <a:t>Archive project status.</a:t>
+            </a:r>
+          </a:p>
+          <a:p>
+            <a:pPr>
+              <a:defRPr sz="2200"/>
+            </a:pPr>
+            <a:r>
+              <a:t>Organisation review.</a:t>
+            </a:r>
+          </a:p>
+          <a:p>
+            <a:pPr>
+              <a:defRPr sz="2200"/>
+            </a:pPr>
+            <a:r>
+              <a:t>Pending documentation issues.</a:t>
+            </a:r>
+          </a:p>
+        </p:txBody>
+      </p:sp>
+    </p:spTree>
+  </p:cSld>
+  <p:clrMapOvr>
+    <a:masterClrMapping/>
+  </p:clrMapOvr>
+</p:sld>
+</file>
+
+<file path=ppt/slides/slide3.xml><?xml version="1.0" encoding="utf-8"?>
+<p:sld xmlns:a="http://schemas.openxmlformats.org/drawingml/2006/main" xmlns:p="http://schemas.openxmlformats.org/presentationml/2006/main" xmlns:r="http://schemas.openxmlformats.org/officeDocument/2006/relationships">
+  <p:cSld>
+    <p:spTree>
+      <p:nvGrpSpPr>
+        <p:cNvPr id="1" name=""/>
+        <p:cNvGrpSpPr/>
+        <p:nvPr/>
+      </p:nvGrpSpPr>
+      <p:grpSpPr/>
+      <p:sp>
+        <p:nvSpPr>
+          <p:cNvPr id="2" name="Title 1"/>
+          <p:cNvSpPr>
+            <a:spLocks noGrp="1"/>
+          </p:cNvSpPr>
+          <p:nvPr>
+            <p:ph type="title"/>
+          </p:nvPr>
+        </p:nvSpPr>
+        <p:spPr/>
+        <p:txBody>
+          <a:bodyPr/>
+          <a:lstStyle/>
+          <a:p>
+            <a:r>
+              <a:t>Financial Overview</a:t>
+            </a:r>
+          </a:p>
+        </p:txBody>
+      </p:sp>
+      <p:sp>
+        <p:nvSpPr>
+          <p:cNvPr id="3" name="Content Placeholder 2"/>
+          <p:cNvSpPr>
+            <a:spLocks noGrp="1"/>
+          </p:cNvSpPr>
+          <p:nvPr>
+            <p:ph idx="1"/>
+          </p:nvPr>
+        </p:nvSpPr>
+        <p:spPr/>
+        <p:txBody>
+          <a:bodyPr/>
+          <a:lstStyle/>
+          <a:p>
+            <a:pPr>
+              <a:defRPr sz="2200"/>
+            </a:pPr>
+            <a:r>
+              <a:t>Overall budget performance remains within expected limits.</a:t>
+            </a:r>
+          </a:p>
+          <a:p>
+            <a:pPr>
+              <a:defRPr sz="2200"/>
+            </a:pPr>
+            <a:r>
+              <a:t>Some operational areas exceeded initial estimates.</a:t>
+            </a:r>
+          </a:p>
+          <a:p>
+            <a:pPr>
+              <a:defRPr sz="2200"/>
+            </a:pPr>
+            <a:r>
+              <a:t>Archive-related costs increased due to additional review requirements.</a:t>
+            </a:r>
+          </a:p>
+        </p:txBody>
+      </p:sp>
+    </p:spTree>
+  </p:cSld>
+  <p:clrMapOvr>
+    <a:masterClrMapping/>
+  </p:clrMapOvr>
+</p:sld>
+</file>
+
+<file path=ppt/slides/slide4.xml><?xml version="1.0" encoding="utf-8"?>
+<p:sld xmlns:a="http://schemas.openxmlformats.org/drawingml/2006/main" xmlns:p="http://schemas.openxmlformats.org/presentationml/2006/main" xmlns:r="http://schemas.openxmlformats.org/officeDocument/2006/relationships">
+  <p:cSld>
+    <p:spTree>
+      <p:nvGrpSpPr>
+        <p:cNvPr id="1" name=""/>
+        <p:cNvGrpSpPr/>
+        <p:nvPr/>
+      </p:nvGrpSpPr>
+      <p:grpSpPr/>
+      <p:sp>
+        <p:nvSpPr>
+          <p:cNvPr id="2" name="Title 1"/>
+          <p:cNvSpPr>
+            <a:spLocks noGrp="1"/>
+          </p:cNvSpPr>
+          <p:nvPr>
+            <p:ph type="title"/>
+          </p:nvPr>
+        </p:nvSpPr>
+        <p:spPr/>
+        <p:txBody>
+          <a:bodyPr/>
+          <a:lstStyle/>
+          <a:p>
+            <a:r>
+              <a:t>Archive Project</a:t>
+            </a:r>
+          </a:p>
+        </p:txBody>
+      </p:sp>
+      <p:sp>
+        <p:nvSpPr>
+          <p:cNvPr id="3" name="Content Placeholder 2"/>
+          <p:cNvSpPr>
+            <a:spLocks noGrp="1"/>
+          </p:cNvSpPr>
+          <p:nvPr>
+            <p:ph idx="1"/>
+          </p:nvPr>
+        </p:nvSpPr>
+        <p:spPr/>
+        <p:txBody>
+          <a:bodyPr/>
+          <a:lstStyle/>
+          <a:p>
+            <a:pPr>
+              <a:defRPr sz="2200"/>
+            </a:pPr>
+            <a:r>
+              <a:t>Digitisation process started successfully.</a:t>
+            </a:r>
+          </a:p>
+          <a:p>
+            <a:pPr>
+              <a:defRPr sz="2200"/>
+            </a:pPr>
+            <a:r>
+              <a:t>Historical documentation requires additional classification.</a:t>
+            </a:r>
+          </a:p>
+          <a:p>
+            <a:pPr>
+              <a:defRPr sz="2200"/>
+            </a:pPr>
+            <a:r>
+              <a:t>Several records do not match current organisational structures.</a:t>
+            </a:r>
+          </a:p>
+          <a:p>
+            <a:pPr>
+              <a:defRPr sz="2200"/>
+            </a:pPr>
+            <a:r>
+              <a:t>Further review recommended before disposal decisions.</a:t>
+            </a:r>
+          </a:p>
+        </p:txBody>
+      </p:sp>
+    </p:spTree>
+  </p:cSld>
+  <p:clrMapOvr>
+    <a:masterClrMapping/>
+  </p:clrMapOvr>
+</p:sld>
+</file>
+
+<file path=ppt/slides/slide5.xml><?xml version="1.0" encoding="utf-8"?>
+<p:sld xmlns:a="http://schemas.openxmlformats.org/drawingml/2006/main" xmlns:p="http://schemas.openxmlformats.org/presentationml/2006/main" xmlns:r="http://schemas.openxmlformats.org/officeDocument/2006/relationships">
+  <p:cSld>
+    <p:spTree>
+      <p:nvGrpSpPr>
+        <p:cNvPr id="1" name=""/>
+        <p:cNvGrpSpPr/>
+        <p:nvPr/>
+      </p:nvGrpSpPr>
+      <p:grpSpPr/>
+      <p:sp>
+        <p:nvSpPr>
+          <p:cNvPr id="2" name="Title 1"/>
+          <p:cNvSpPr>
+            <a:spLocks noGrp="1"/>
+          </p:cNvSpPr>
+          <p:nvPr>
+            <p:ph type="title"/>
+          </p:nvPr>
+        </p:nvSpPr>
+        <p:spPr/>
+        <p:txBody>
+          <a:bodyPr/>
+          <a:lstStyle/>
+          <a:p>
+            <a:r>
+              <a:t>Organisation Changes</a:t>
+            </a:r>
+          </a:p>
+        </p:txBody>
+      </p:sp>
+      <p:sp>
+        <p:nvSpPr>
+          <p:cNvPr id="3" name="Content Placeholder 2"/>
+          <p:cNvSpPr>
+            <a:spLocks noGrp="1"/>
+          </p:cNvSpPr>
+          <p:nvPr>
+            <p:ph idx="1"/>
+          </p:nvPr>
+        </p:nvSpPr>
+        <p:spPr/>
+        <p:txBody>
+          <a:bodyPr/>
+          <a:lstStyle/>
+          <a:p>
+            <a:pPr>
+              <a:defRPr sz="2200"/>
+            </a:pPr>
+            <a:r>
+              <a:t>Department responsibilities have been updated.</a:t>
+            </a:r>
+          </a:p>
+          <a:p>
+            <a:pPr>
+              <a:defRPr sz="2200"/>
+            </a:pPr>
+            <a:r>
+              <a:t>Previous structures remain available in archived documentation.</a:t>
+            </a:r>
+          </a:p>
+          <a:p>
+            <a:pPr>
+              <a:defRPr sz="2200"/>
+            </a:pPr>
+            <a:r>
+              <a:t>Historical references should be preserved.</a:t>
+            </a:r>
+          </a:p>
+        </p:txBody>
+      </p:sp>
+    </p:spTree>
+  </p:cSld>
+  <p:clrMapOvr>
+    <a:masterClrMapping/>
+  </p:clrMapOvr>
+</p:sld>
+</file>
+
+<file path=ppt/slides/slide6.xml><?xml version="1.0" encoding="utf-8"?>
+<p:sld xmlns:a="http://schemas.openxmlformats.org/drawingml/2006/main" xmlns:p="http://schemas.openxmlformats.org/presentationml/2006/main" xmlns:r="http://schemas.openxmlformats.org/officeDocument/2006/relationships">
+  <p:cSld>
+    <p:spTree>
+      <p:nvGrpSpPr>
+        <p:cNvPr id="1" name=""/>
+        <p:cNvGrpSpPr/>
+        <p:nvPr/>
+      </p:nvGrpSpPr>
+      <p:grpSpPr/>
+      <p:sp>
+        <p:nvSpPr>
+          <p:cNvPr id="2" name="Title 1"/>
+          <p:cNvSpPr>
+            <a:spLocks noGrp="1"/>
+          </p:cNvSpPr>
+          <p:nvPr>
+            <p:ph type="title"/>
+          </p:nvPr>
+        </p:nvSpPr>
+        <p:spPr/>
+        <p:txBody>
+          <a:bodyPr/>
+          <a:lstStyle/>
+          <a:p>
+            <a:r>
+              <a:t>Open Questions</a:t>
+            </a:r>
+          </a:p>
+        </p:txBody>
+      </p:sp>
+      <p:sp>
+        <p:nvSpPr>
+          <p:cNvPr id="3" name="Content Placeholder 2"/>
+          <p:cNvSpPr>
+            <a:spLocks noGrp="1"/>
+          </p:cNvSpPr>
+          <p:nvPr>
+            <p:ph idx="1"/>
+          </p:nvPr>
+        </p:nvSpPr>
+        <p:spPr/>
+        <p:txBody>
+          <a:bodyPr/>
+          <a:lstStyle/>
+          <a:p>
+            <a:pPr>
+              <a:defRPr sz="2200"/>
+            </a:pPr>
+            <a:r>
+              <a:t>Employee registry differences.</a:t>
+            </a:r>
+          </a:p>
+          <a:p>
+            <a:pPr>
+              <a:defRPr sz="2200"/>
+            </a:pPr>
+            <a:r>
+              <a:t>Historical department references.</a:t>
+            </a:r>
+          </a:p>
+          <a:p>
+            <a:pPr>
+              <a:defRPr sz="2200"/>
+            </a:pPr>
+            <a:r>
+              <a:t>Unclassified archive material.</a:t>
+            </a:r>
+          </a:p>
+          <a:p>
+            <a:pPr>
+              <a:defRPr sz="2200"/>
+            </a:pPr>
+            <a:r>
+              <a:t>Pending management decisions.</a:t>
             </a:r>
           </a:p>
         </p:txBody>

</xml_diff>